<commit_message>
docs(ai-skill-studio): fix slide 6/7 deliverable overflow and add text-fit validator
</commit_message>
<xml_diff>
--- a/docs/commercial/business-32-ai-skill-studio/customer-package/Business32_Master_Proposal_10p.pptx
+++ b/docs/commercial/business-32-ai-skill-studio/customer-package/Business32_Master_Proposal_10p.pptx
@@ -8337,7 +8337,7 @@
         <p:spPr>
           <a:xfrm>
             <a:off x="868680" y="2743200"/>
-            <a:ext cx="4937760" cy="365760"/>
+            <a:ext cx="2468880" cy="457200"/>
           </a:xfrm>
           <a:prstGeom prst="rect">
             <a:avLst/>
@@ -8370,8 +8370,8 @@
         </p:nvSpPr>
         <p:spPr>
           <a:xfrm>
-            <a:off x="868680" y="3163824"/>
-            <a:ext cx="4937760" cy="365760"/>
+            <a:off x="868680" y="3246120"/>
+            <a:ext cx="2468880" cy="457200"/>
           </a:xfrm>
           <a:prstGeom prst="rect">
             <a:avLst/>
@@ -8404,8 +8404,8 @@
         </p:nvSpPr>
         <p:spPr>
           <a:xfrm>
-            <a:off x="868680" y="3584448"/>
-            <a:ext cx="4937760" cy="365760"/>
+            <a:off x="868680" y="3749039"/>
+            <a:ext cx="2468880" cy="457200"/>
           </a:xfrm>
           <a:prstGeom prst="rect">
             <a:avLst/>
@@ -8438,8 +8438,8 @@
         </p:nvSpPr>
         <p:spPr>
           <a:xfrm>
-            <a:off x="868680" y="4005072"/>
-            <a:ext cx="4937760" cy="365760"/>
+            <a:off x="868680" y="4251960"/>
+            <a:ext cx="2468880" cy="457200"/>
           </a:xfrm>
           <a:prstGeom prst="rect">
             <a:avLst/>
@@ -8472,8 +8472,8 @@
         </p:nvSpPr>
         <p:spPr>
           <a:xfrm>
-            <a:off x="868680" y="4425696"/>
-            <a:ext cx="4937760" cy="365760"/>
+            <a:off x="868680" y="4754880"/>
+            <a:ext cx="2468880" cy="457200"/>
           </a:xfrm>
           <a:prstGeom prst="rect">
             <a:avLst/>
@@ -8506,8 +8506,8 @@
         </p:nvSpPr>
         <p:spPr>
           <a:xfrm>
-            <a:off x="868680" y="4846320"/>
-            <a:ext cx="4937760" cy="365760"/>
+            <a:off x="3520439" y="2743200"/>
+            <a:ext cx="2468880" cy="457200"/>
           </a:xfrm>
           <a:prstGeom prst="rect">
             <a:avLst/>
@@ -8540,8 +8540,8 @@
         </p:nvSpPr>
         <p:spPr>
           <a:xfrm>
-            <a:off x="868680" y="5266944"/>
-            <a:ext cx="4937760" cy="365760"/>
+            <a:off x="3520439" y="3246120"/>
+            <a:ext cx="2468880" cy="457200"/>
           </a:xfrm>
           <a:prstGeom prst="rect">
             <a:avLst/>
@@ -8574,8 +8574,8 @@
         </p:nvSpPr>
         <p:spPr>
           <a:xfrm>
-            <a:off x="868680" y="5687568"/>
-            <a:ext cx="4937760" cy="365760"/>
+            <a:off x="3520439" y="3749039"/>
+            <a:ext cx="2468880" cy="457200"/>
           </a:xfrm>
           <a:prstGeom prst="rect">
             <a:avLst/>
@@ -8608,8 +8608,8 @@
         </p:nvSpPr>
         <p:spPr>
           <a:xfrm>
-            <a:off x="868680" y="6108192"/>
-            <a:ext cx="4937760" cy="365760"/>
+            <a:off x="3520439" y="4251960"/>
+            <a:ext cx="2468880" cy="457200"/>
           </a:xfrm>
           <a:prstGeom prst="rect">
             <a:avLst/>
@@ -9603,7 +9603,7 @@
         <p:spPr>
           <a:xfrm>
             <a:off x="868680" y="2743200"/>
-            <a:ext cx="4937760" cy="365760"/>
+            <a:ext cx="2468880" cy="457200"/>
           </a:xfrm>
           <a:prstGeom prst="rect">
             <a:avLst/>
@@ -9636,8 +9636,8 @@
         </p:nvSpPr>
         <p:spPr>
           <a:xfrm>
-            <a:off x="868680" y="3163824"/>
-            <a:ext cx="4937760" cy="365760"/>
+            <a:off x="868680" y="3246120"/>
+            <a:ext cx="2468880" cy="457200"/>
           </a:xfrm>
           <a:prstGeom prst="rect">
             <a:avLst/>
@@ -9670,8 +9670,8 @@
         </p:nvSpPr>
         <p:spPr>
           <a:xfrm>
-            <a:off x="868680" y="3584448"/>
-            <a:ext cx="4937760" cy="365760"/>
+            <a:off x="868680" y="3749039"/>
+            <a:ext cx="2468880" cy="457200"/>
           </a:xfrm>
           <a:prstGeom prst="rect">
             <a:avLst/>
@@ -9704,8 +9704,8 @@
         </p:nvSpPr>
         <p:spPr>
           <a:xfrm>
-            <a:off x="868680" y="4005072"/>
-            <a:ext cx="4937760" cy="365760"/>
+            <a:off x="868680" y="4251960"/>
+            <a:ext cx="2468880" cy="457200"/>
           </a:xfrm>
           <a:prstGeom prst="rect">
             <a:avLst/>
@@ -9738,8 +9738,8 @@
         </p:nvSpPr>
         <p:spPr>
           <a:xfrm>
-            <a:off x="868680" y="4425696"/>
-            <a:ext cx="4937760" cy="365760"/>
+            <a:off x="868680" y="4754880"/>
+            <a:ext cx="2468880" cy="457200"/>
           </a:xfrm>
           <a:prstGeom prst="rect">
             <a:avLst/>
@@ -9772,8 +9772,8 @@
         </p:nvSpPr>
         <p:spPr>
           <a:xfrm>
-            <a:off x="868680" y="4846320"/>
-            <a:ext cx="4937760" cy="365760"/>
+            <a:off x="3520439" y="2743200"/>
+            <a:ext cx="2468880" cy="457200"/>
           </a:xfrm>
           <a:prstGeom prst="rect">
             <a:avLst/>
@@ -9806,8 +9806,8 @@
         </p:nvSpPr>
         <p:spPr>
           <a:xfrm>
-            <a:off x="868680" y="5266944"/>
-            <a:ext cx="4937760" cy="365760"/>
+            <a:off x="3520439" y="3246120"/>
+            <a:ext cx="2468880" cy="457200"/>
           </a:xfrm>
           <a:prstGeom prst="rect">
             <a:avLst/>
@@ -9840,8 +9840,8 @@
         </p:nvSpPr>
         <p:spPr>
           <a:xfrm>
-            <a:off x="868680" y="5687568"/>
-            <a:ext cx="4937760" cy="365760"/>
+            <a:off x="3520439" y="3749039"/>
+            <a:ext cx="2468880" cy="457200"/>
           </a:xfrm>
           <a:prstGeom prst="rect">
             <a:avLst/>
@@ -9874,8 +9874,8 @@
         </p:nvSpPr>
         <p:spPr>
           <a:xfrm>
-            <a:off x="868680" y="6108192"/>
-            <a:ext cx="4937760" cy="365760"/>
+            <a:off x="3520439" y="4251960"/>
+            <a:ext cx="2468880" cy="457200"/>
           </a:xfrm>
           <a:prstGeom prst="rect">
             <a:avLst/>

</xml_diff>